<commit_message>
W02 D4: notebooks re-executed cold for the final proof, conditional wording in the escalated solution, and two speaker notes rephrased
Co-Authored-By: Claude Opus 5.5 <noreply@anthropic.com>
Claude-Session: https://claude.ai/code/session_013SfjkqhEEdHpVQNKrUAyRW
</commit_message>
<xml_diff>
--- a/content/W02/D4/slides/C2_W02_D04_half1_STUDENT.pptx
+++ b/content/W02/D4/slides/C2_W02_D04_half1_STUDENT.pptx
@@ -2194,12 +2194,12 @@
           <a:lstStyle/>
           <a:p>
             <a:r>
-              <a:t>LIVE, 4 minutes. This MergeError is not the two-minute kind of error: it is the check that</a:t>
-            </a:r>
-          </a:p>
-          <a:p>
-            <a:r>
-              <a:t>catches the trap, so it gets the time. Read the last line aloud: which side, which promise.</a:t>
+              <a:t>LIVE, 4 minutes. This MergeError is the check that catches the trap, so it gets the time, unlike the two-minute</a:t>
+            </a:r>
+          </a:p>
+          <a:p>
+            <a:r>
+              <a:t>runtime errors. Read the last line aloud: which side, which promise.</a:t>
             </a:r>
           </a:p>
           <a:p>

</xml_diff>

<commit_message>
W02 D4: the self-check's 142 of 142, the pivot's Rs 3,37,267, and the decision S28 misleads
The take-home self-check said a dropped segment shows 153 bought out of 153; recomputed from
the take-home files, the mistake shows 142 of 142, 100 percent, as the day sheet says. The
deck, the study notes and the day sheet carried Rs 3,37,266 for Retail-Plus's averaged Q2,
where the notebook prints Rs 3,37,267 and the tier's two quarters add to its Rs 7,49,286
only with 267. Slide S28 now names the decision the 100 percent would mislead.

Co-Authored-By: Claude Opus 5.5 <noreply@anthropic.com>
Claude-Session: https://claude.ai/code/session_01P7zaoR4dQ5pzBFnsX549JQ
</commit_message>
<xml_diff>
--- a/content/W02/D4/slides/C2_W02_D04_half1_STUDENT.pptx
+++ b/content/W02/D4/slides/C2_W02_D04_half1_STUDENT.pptx
@@ -17577,7 +17577,7 @@
                 </a:solidFill>
                 <a:latin typeface="Calibri"/>
               </a:rPr>
-              <a:t>Week 2 Day 4: the customer table Marketing refreshes every Monday</a:t>
+              <a:t>Week 2, Day 4. The customer table Marketing refreshes every Monday</a:t>
             </a:r>
           </a:p>
         </p:txBody>
@@ -21383,7 +21383,7 @@
                 </a:solidFill>
                 <a:latin typeface="Calibri"/>
               </a:rPr>
-              <a:t>Week 2 Day 4: the customer table Marketing refreshes every Monday</a:t>
+              <a:t>Week 2, Day 4. The customer table Marketing refreshes every Monday</a:t>
             </a:r>
           </a:p>
         </p:txBody>
@@ -31619,7 +31619,7 @@
         </p:nvSpPr>
         <p:spPr>
           <a:xfrm>
-            <a:off x="530352" y="1956816"/>
+            <a:off x="530352" y="1863598"/>
             <a:ext cx="11130991" cy="1719580"/>
           </a:xfrm>
           <a:prstGeom prst="roundRect">
@@ -31671,7 +31671,7 @@
         </p:nvSpPr>
         <p:spPr>
           <a:xfrm>
-            <a:off x="713232" y="2084832"/>
+            <a:off x="713232" y="1991614"/>
             <a:ext cx="91440" cy="91440"/>
           </a:xfrm>
           <a:prstGeom prst="ellipse">
@@ -31715,7 +31715,7 @@
         </p:nvSpPr>
         <p:spPr>
           <a:xfrm>
-            <a:off x="868680" y="2084832"/>
+            <a:off x="868680" y="1991614"/>
             <a:ext cx="91440" cy="91440"/>
           </a:xfrm>
           <a:prstGeom prst="ellipse">
@@ -31759,7 +31759,7 @@
         </p:nvSpPr>
         <p:spPr>
           <a:xfrm>
-            <a:off x="1024128" y="2084832"/>
+            <a:off x="1024128" y="1991614"/>
             <a:ext cx="91440" cy="91440"/>
           </a:xfrm>
           <a:prstGeom prst="ellipse">
@@ -31803,7 +31803,7 @@
         </p:nvSpPr>
         <p:spPr>
           <a:xfrm>
-            <a:off x="804671" y="2286000"/>
+            <a:off x="804671" y="2192782"/>
             <a:ext cx="10673791" cy="1317244"/>
           </a:xfrm>
           <a:prstGeom prst="rect">
@@ -31906,7 +31906,7 @@
         </p:nvSpPr>
         <p:spPr>
           <a:xfrm>
-            <a:off x="530352" y="3840988"/>
+            <a:off x="530352" y="3747770"/>
             <a:ext cx="5428335" cy="698500"/>
           </a:xfrm>
           <a:prstGeom prst="rect">
@@ -31941,7 +31941,7 @@
         </p:nvSpPr>
         <p:spPr>
           <a:xfrm>
-            <a:off x="530352" y="4576064"/>
+            <a:off x="530352" y="4482846"/>
             <a:ext cx="5428335" cy="168656"/>
           </a:xfrm>
           <a:prstGeom prst="rect">
@@ -31976,7 +31976,7 @@
         </p:nvSpPr>
         <p:spPr>
           <a:xfrm>
-            <a:off x="530352" y="4777232"/>
+            <a:off x="530352" y="4684014"/>
             <a:ext cx="5428335" cy="193421"/>
           </a:xfrm>
           <a:prstGeom prst="rect">
@@ -32011,7 +32011,7 @@
         </p:nvSpPr>
         <p:spPr>
           <a:xfrm>
-            <a:off x="530352" y="5029708"/>
+            <a:off x="530352" y="4936490"/>
             <a:ext cx="5428335" cy="10972"/>
           </a:xfrm>
           <a:prstGeom prst="rect">
@@ -32055,7 +32055,7 @@
         </p:nvSpPr>
         <p:spPr>
           <a:xfrm>
-            <a:off x="6233007" y="3840988"/>
+            <a:off x="6233007" y="3747770"/>
             <a:ext cx="5428335" cy="698500"/>
           </a:xfrm>
           <a:prstGeom prst="rect">
@@ -32090,7 +32090,7 @@
         </p:nvSpPr>
         <p:spPr>
           <a:xfrm>
-            <a:off x="6233007" y="4576064"/>
+            <a:off x="6233007" y="4482846"/>
             <a:ext cx="5428335" cy="168656"/>
           </a:xfrm>
           <a:prstGeom prst="rect">
@@ -32125,7 +32125,7 @@
         </p:nvSpPr>
         <p:spPr>
           <a:xfrm>
-            <a:off x="6233007" y="4777232"/>
+            <a:off x="6233007" y="4684014"/>
             <a:ext cx="5428335" cy="193421"/>
           </a:xfrm>
           <a:prstGeom prst="rect">
@@ -32160,7 +32160,7 @@
         </p:nvSpPr>
         <p:spPr>
           <a:xfrm>
-            <a:off x="6233007" y="5029708"/>
+            <a:off x="6233007" y="4936490"/>
             <a:ext cx="5428335" cy="10972"/>
           </a:xfrm>
           <a:prstGeom prst="rect">
@@ -32198,7 +32198,144 @@
       </p:sp>
       <p:sp>
         <p:nvSpPr>
-          <p:cNvPr id="22" name="Oval 21"/>
+          <p:cNvPr id="22" name="Rounded Rectangle 21"/>
+          <p:cNvSpPr/>
+          <p:nvPr/>
+        </p:nvSpPr>
+        <p:spPr>
+          <a:xfrm>
+            <a:off x="530352" y="5210810"/>
+            <a:ext cx="11130991" cy="807720"/>
+          </a:xfrm>
+          <a:prstGeom prst="roundRect">
+            <a:avLst>
+              <a:gd name="adj" fmla="val 8000"/>
+            </a:avLst>
+          </a:prstGeom>
+          <a:solidFill>
+            <a:srgbClr val="F7F5FD"/>
+          </a:solidFill>
+          <a:ln w="9525">
+            <a:solidFill>
+              <a:srgbClr val="E4E1F1"/>
+            </a:solidFill>
+          </a:ln>
+          <a:effectLst/>
+        </p:spPr>
+        <p:style>
+          <a:lnRef idx="1">
+            <a:schemeClr val="accent1"/>
+          </a:lnRef>
+          <a:fillRef idx="3">
+            <a:schemeClr val="accent1"/>
+          </a:fillRef>
+          <a:effectRef idx="2">
+            <a:schemeClr val="accent1"/>
+          </a:effectRef>
+          <a:fontRef idx="minor">
+            <a:schemeClr val="lt1"/>
+          </a:fontRef>
+        </p:style>
+        <p:txBody>
+          <a:bodyPr rtlCol="0" anchor="ctr" wrap="square"/>
+          <a:lstStyle/>
+          <a:p>
+            <a:pPr algn="ctr"/>
+          </a:p>
+        </p:txBody>
+      </p:sp>
+      <p:sp>
+        <p:nvSpPr>
+          <p:cNvPr id="23" name="Rounded Rectangle 22"/>
+          <p:cNvSpPr/>
+          <p:nvPr/>
+        </p:nvSpPr>
+        <p:spPr>
+          <a:xfrm>
+            <a:off x="676656" y="5338826"/>
+            <a:ext cx="45720" cy="551688"/>
+          </a:xfrm>
+          <a:prstGeom prst="roundRect">
+            <a:avLst>
+              <a:gd name="adj" fmla="val 50000"/>
+            </a:avLst>
+          </a:prstGeom>
+          <a:solidFill>
+            <a:srgbClr val="5B3FD6"/>
+          </a:solidFill>
+          <a:ln>
+            <a:noFill/>
+          </a:ln>
+          <a:effectLst/>
+        </p:spPr>
+        <p:style>
+          <a:lnRef idx="1">
+            <a:schemeClr val="accent1"/>
+          </a:lnRef>
+          <a:fillRef idx="3">
+            <a:schemeClr val="accent1"/>
+          </a:fillRef>
+          <a:effectRef idx="2">
+            <a:schemeClr val="accent1"/>
+          </a:effectRef>
+          <a:fontRef idx="minor">
+            <a:schemeClr val="lt1"/>
+          </a:fontRef>
+        </p:style>
+        <p:txBody>
+          <a:bodyPr rtlCol="0" anchor="ctr" wrap="square"/>
+          <a:lstStyle/>
+          <a:p>
+            <a:pPr algn="ctr"/>
+          </a:p>
+        </p:txBody>
+      </p:sp>
+      <p:sp>
+        <p:nvSpPr>
+          <p:cNvPr id="24" name="TextBox 23"/>
+          <p:cNvSpPr txBox="1"/>
+          <p:nvPr/>
+        </p:nvSpPr>
+        <p:spPr>
+          <a:xfrm>
+            <a:off x="877824" y="5329682"/>
+            <a:ext cx="10564063" cy="624840"/>
+          </a:xfrm>
+          <a:prstGeom prst="rect">
+            <a:avLst/>
+          </a:prstGeom>
+          <a:noFill/>
+        </p:spPr>
+        <p:txBody>
+          <a:bodyPr wrap="square" anchor="ctr" lIns="0" rIns="0" tIns="0" bIns="0">
+            <a:spAutoFit/>
+          </a:bodyPr>
+          <a:lstStyle/>
+          <a:p>
+            <a:r>
+              <a:rPr sz="1500" b="1">
+                <a:solidFill>
+                  <a:srgbClr val="5B3FD6"/>
+                </a:solidFill>
+                <a:latin typeface="Calibri"/>
+              </a:rPr>
+              <a:t>The decision it misleads. </a:t>
+            </a:r>
+            <a:r>
+              <a:rPr sz="1500" b="0" i="0">
+                <a:solidFill>
+                  <a:srgbClr val="1A1440"/>
+                </a:solidFill>
+                <a:latin typeface="Calibri"/>
+              </a:rPr>
+              <a:t>A sale that seems to turn every customer it reached into a buyer goes into next quarter's plan as the lever that always works, and nobody asks whom it reached and lost.</a:t>
+            </a:r>
+          </a:p>
+        </p:txBody>
+      </p:sp>
+      <p:sp>
+        <p:nvSpPr>
+          <p:cNvPr id="25" name="Oval 24"/>
           <p:cNvSpPr/>
           <p:nvPr/>
         </p:nvSpPr>
@@ -32242,7 +32379,7 @@
       </p:sp>
       <p:sp>
         <p:nvSpPr>
-          <p:cNvPr id="23" name="TextBox 22"/>
+          <p:cNvPr id="26" name="TextBox 25"/>
           <p:cNvSpPr txBox="1"/>
           <p:nvPr/>
         </p:nvSpPr>
@@ -32277,7 +32414,7 @@
       </p:sp>
       <p:sp>
         <p:nvSpPr>
-          <p:cNvPr id="24" name="Oval 23"/>
+          <p:cNvPr id="27" name="Oval 26"/>
           <p:cNvSpPr/>
           <p:nvPr/>
         </p:nvSpPr>
@@ -32321,7 +32458,7 @@
       </p:sp>
       <p:sp>
         <p:nvSpPr>
-          <p:cNvPr id="25" name="TextBox 24"/>
+          <p:cNvPr id="28" name="TextBox 27"/>
           <p:cNvSpPr txBox="1"/>
           <p:nvPr/>
         </p:nvSpPr>
@@ -32356,7 +32493,7 @@
       </p:sp>
       <p:sp>
         <p:nvSpPr>
-          <p:cNvPr id="26" name="Oval 25"/>
+          <p:cNvPr id="29" name="Oval 28"/>
           <p:cNvSpPr/>
           <p:nvPr/>
         </p:nvSpPr>
@@ -32400,7 +32537,7 @@
       </p:sp>
       <p:sp>
         <p:nvSpPr>
-          <p:cNvPr id="27" name="TextBox 26"/>
+          <p:cNvPr id="30" name="TextBox 29"/>
           <p:cNvSpPr txBox="1"/>
           <p:nvPr/>
         </p:nvSpPr>
@@ -32435,7 +32572,7 @@
       </p:sp>
       <p:sp>
         <p:nvSpPr>
-          <p:cNvPr id="28" name="Oval 27"/>
+          <p:cNvPr id="31" name="Oval 30"/>
           <p:cNvSpPr/>
           <p:nvPr/>
         </p:nvSpPr>
@@ -32479,7 +32616,7 @@
       </p:sp>
       <p:sp>
         <p:nvSpPr>
-          <p:cNvPr id="29" name="TextBox 28"/>
+          <p:cNvPr id="32" name="TextBox 31"/>
           <p:cNvSpPr txBox="1"/>
           <p:nvPr/>
         </p:nvSpPr>
@@ -32514,7 +32651,7 @@
       </p:sp>
       <p:sp>
         <p:nvSpPr>
-          <p:cNvPr id="30" name="TextBox 29"/>
+          <p:cNvPr id="33" name="TextBox 32"/>
           <p:cNvSpPr txBox="1"/>
           <p:nvPr/>
         </p:nvSpPr>
@@ -35748,7 +35885,7 @@
                 </a:solidFill>
                 <a:latin typeface="Calibri"/>
               </a:rPr>
-              <a:t>Week 2 Day 4: the customer table Marketing refreshes every Monday</a:t>
+              <a:t>Week 2, Day 4. The customer table Marketing refreshes every Monday</a:t>
             </a:r>
           </a:p>
         </p:txBody>
@@ -39617,7 +39754,7 @@
                 </a:solidFill>
                 <a:latin typeface="Calibri"/>
               </a:rPr>
-              <a:t>Rs 4,12,019 to Rs 3,37,266</a:t>
+              <a:t>Rs 4,12,019 to Rs 3,37,267</a:t>
             </a:r>
           </a:p>
         </p:txBody>
@@ -53163,7 +53300,7 @@
                 </a:solidFill>
                 <a:latin typeface="Calibri"/>
               </a:rPr>
-              <a:t>Week 2 Day 4: the customer table Marketing refreshes every Monday</a:t>
+              <a:t>Week 2, Day 4. The customer table Marketing refreshes every Monday</a:t>
             </a:r>
           </a:p>
         </p:txBody>

</xml_diff>